<commit_message>
Updated files from current Spanish folder on Teams
Updated files from current Teams folder - slides, Refinement, etc.
</commit_message>
<xml_diff>
--- a/training/Latin American Spanish (es-419)/Diapositivas para los Módulos - es [COBT-T]/02 Derechos de Autor - WT diapositivas.pptx
+++ b/training/Latin American Spanish (es-419)/Diapositivas para los Módulos - es [COBT-T]/02 Derechos de Autor - WT diapositivas.pptx
@@ -155,28 +155,6 @@
 </p:cmAuthorLst>
 </file>
 
-<file path=ppt/comments/modernComment_104_7EC3E1EB.xml><?xml version="1.0" encoding="utf-8"?>
-<p188:cmLst xmlns:a="http://schemas.openxmlformats.org/drawingml/2006/main" xmlns:r="http://schemas.openxmlformats.org/officeDocument/2006/relationships" xmlns:p188="http://schemas.microsoft.com/office/powerpoint/2018/8/main">
-  <p188:cm id="{F4C90341-E7F4-894C-AA8D-8C15D6496EC8}" authorId="{6D5E46F2-152B-65D0-AD33-4271C3B1668D}" created="2023-02-28T20:58:14.804">
-    <ac:deMkLst xmlns:ac="http://schemas.microsoft.com/office/drawing/2013/main/command">
-      <pc:docMk xmlns:pc="http://schemas.microsoft.com/office/powerpoint/2013/main/command"/>
-      <pc:sldMk xmlns:pc="http://schemas.microsoft.com/office/powerpoint/2013/main/command" cId="2126766571" sldId="260"/>
-      <ac:spMk id="18" creationId="{4694CCB8-A161-4308-BC33-DD746CEBFA8D}"/>
-    </ac:deMkLst>
-    <p188:txBody>
-      <a:bodyPr/>
-      <a:lstStyle/>
-      <a:p>
-        <a:r>
-          <a:rPr lang="en-US"/>
-          <a:t>How have you been referring to copyright? Derechos de autor or derechos del autor</a:t>
-        </a:r>
-      </a:p>
-    </p188:txBody>
-  </p188:cm>
-</p188:cmLst>
-</file>
-
 <file path=ppt/notesMasters/notesMaster1.xml><?xml version="1.0" encoding="utf-8"?>
 <p:notesMaster xmlns:a="http://schemas.openxmlformats.org/drawingml/2006/main" xmlns:r="http://schemas.openxmlformats.org/officeDocument/2006/relationships" xmlns:p="http://schemas.openxmlformats.org/presentationml/2006/main">
   <p:cSld>
@@ -259,7 +237,7 @@
           <a:p>
             <a:fld id="{AC6AA070-92F4-A447-BB88-F5E94FF9CF8B}" type="datetimeFigureOut">
               <a:rPr lang="en-US" smtClean="0"/>
-              <a:t>3/15/23</a:t>
+              <a:t>4/15/25</a:t>
             </a:fld>
             <a:endParaRPr lang="en-US"/>
           </a:p>
@@ -570,6 +548,10 @@
           <a:bodyPr/>
           <a:lstStyle/>
           <a:p>
+            <a:r>
+              <a:rPr lang="es-MX"/>
+              <a:t>04/2025</a:t>
+            </a:r>
             <a:endParaRPr lang="es-MX" dirty="0"/>
           </a:p>
         </p:txBody>
@@ -1214,7 +1196,7 @@
           <a:p>
             <a:fld id="{2D176C0A-5C67-429D-B78E-C0F7FE360763}" type="datetimeFigureOut">
               <a:rPr lang="en-US" smtClean="0"/>
-              <a:t>3/15/23</a:t>
+              <a:t>4/15/25</a:t>
             </a:fld>
             <a:endParaRPr lang="en-US"/>
           </a:p>
@@ -2671,7 +2653,7 @@
           <p:nvPr/>
         </p:nvPicPr>
         <p:blipFill rotWithShape="1">
-          <a:blip r:embed="rId4">
+          <a:blip r:embed="rId3">
             <a:extLst>
               <a:ext uri="{28A0092B-C50C-407E-A947-70E740481C1C}">
                 <a14:useLocalDpi xmlns:a14="http://schemas.microsoft.com/office/drawing/2010/main" val="0"/>
@@ -3116,11 +3098,6 @@
   <p:clrMapOvr>
     <a:masterClrMapping/>
   </p:clrMapOvr>
-  <p:extLst>
-    <p:ext uri="{6950BFC3-D8DA-4A85-94F7-54DA5524770B}">
-      <p188:commentRel xmlns:p188="http://schemas.microsoft.com/office/powerpoint/2018/8/main" r:id="rId3"/>
-    </p:ext>
-  </p:extLst>
 </p:sld>
 </file>
 
@@ -3779,23 +3756,7 @@
                   <a:srgbClr val="B95659"/>
                 </a:solidFill>
               </a:rPr>
-              <a:t>Se </a:t>
-            </a:r>
-            <a:r>
-              <a:rPr lang="en-US" sz="3600" b="1" dirty="0" err="1">
-                <a:solidFill>
-                  <a:srgbClr val="B95659"/>
-                </a:solidFill>
-              </a:rPr>
-              <a:t>Debe</a:t>
-            </a:r>
-            <a:r>
-              <a:rPr lang="en-US" sz="3600" b="1" dirty="0">
-                <a:solidFill>
-                  <a:srgbClr val="B95659"/>
-                </a:solidFill>
-              </a:rPr>
-              <a:t>:</a:t>
+              <a:t>Se Debe:</a:t>
             </a:r>
             <a:r>
               <a:rPr lang="en-US" sz="3200" b="1" dirty="0">
@@ -3811,7 +3772,7 @@
             </a:r>
             <a:r>
               <a:rPr lang="en-US" sz="2400" dirty="0" err="1"/>
-              <a:t>atribucion</a:t>
+              <a:t>atribución</a:t>
             </a:r>
             <a:r>
               <a:rPr lang="en-US" sz="2400" dirty="0"/>
@@ -4461,7 +4422,7 @@
                   <a:srgbClr val="B95659"/>
                 </a:solidFill>
               </a:rPr>
-              <a:t>licensia</a:t>
+              <a:t>licencia</a:t>
             </a:r>
             <a:r>
               <a:rPr lang="en-US" sz="3200" b="1" dirty="0">
@@ -7967,7 +7928,7 @@
           <a:p>
             <a:r>
               <a:rPr lang="en-US" dirty="0" err="1"/>
-              <a:t>Abilidad</a:t>
+              <a:t>Habilidad</a:t>
             </a:r>
             <a:r>
               <a:rPr lang="en-US" dirty="0"/>
@@ -8626,12 +8587,20 @@
               </a:buClr>
             </a:pPr>
             <a:r>
+              <a:rPr lang="en-US" sz="2800" dirty="0">
+                <a:solidFill>
+                  <a:schemeClr val="tx2"/>
+                </a:solidFill>
+              </a:rPr>
+              <a:t>Esta </a:t>
+            </a:r>
+            <a:r>
               <a:rPr lang="en-US" sz="2800" dirty="0" err="1">
                 <a:solidFill>
                   <a:schemeClr val="tx2"/>
                 </a:solidFill>
               </a:rPr>
-              <a:t>Esta</a:t>
+              <a:t>licencia</a:t>
             </a:r>
             <a:r>
               <a:rPr lang="en-US" sz="2800" dirty="0">
@@ -8647,7 +8616,7 @@
                   <a:schemeClr val="tx2"/>
                 </a:solidFill>
               </a:rPr>
-              <a:t>licencia</a:t>
+              <a:t>permite</a:t>
             </a:r>
             <a:r>
               <a:rPr lang="en-US" sz="2800" dirty="0">
@@ -8655,6 +8624,22 @@
                   <a:schemeClr val="tx2"/>
                 </a:solidFill>
               </a:rPr>
+              <a:t> que </a:t>
+            </a:r>
+            <a:r>
+              <a:rPr lang="en-US" sz="2800" dirty="0" err="1">
+                <a:solidFill>
+                  <a:schemeClr val="tx2"/>
+                </a:solidFill>
+              </a:rPr>
+              <a:t>los</a:t>
+            </a:r>
+            <a:r>
+              <a:rPr lang="en-US" sz="2800" dirty="0">
+                <a:solidFill>
+                  <a:schemeClr val="tx2"/>
+                </a:solidFill>
+              </a:rPr>
               <a:t> </a:t>
             </a:r>
             <a:r>
@@ -8663,39 +8648,7 @@
                   <a:schemeClr val="tx2"/>
                 </a:solidFill>
               </a:rPr>
-              <a:t>permite</a:t>
-            </a:r>
-            <a:r>
-              <a:rPr lang="en-US" sz="2800" dirty="0">
-                <a:solidFill>
-                  <a:schemeClr val="tx2"/>
-                </a:solidFill>
-              </a:rPr>
-              <a:t> que </a:t>
-            </a:r>
-            <a:r>
-              <a:rPr lang="en-US" sz="2800" dirty="0" err="1">
-                <a:solidFill>
-                  <a:schemeClr val="tx2"/>
-                </a:solidFill>
-              </a:rPr>
-              <a:t>los</a:t>
-            </a:r>
-            <a:r>
-              <a:rPr lang="en-US" sz="2800" dirty="0">
-                <a:solidFill>
-                  <a:schemeClr val="tx2"/>
-                </a:solidFill>
-              </a:rPr>
-              <a:t> </a:t>
-            </a:r>
-            <a:r>
-              <a:rPr lang="en-US" sz="2800" dirty="0" err="1">
-                <a:solidFill>
-                  <a:schemeClr val="tx2"/>
-                </a:solidFill>
-              </a:rPr>
-              <a:t>reusadores</a:t>
+              <a:t>usuarios</a:t>
             </a:r>
             <a:r>
               <a:rPr lang="en-US" sz="2800" dirty="0">
@@ -10938,15 +10891,15 @@
 <file path=customXml/itemProps1.xml><?xml version="1.0" encoding="utf-8"?>
 <ds:datastoreItem xmlns:ds="http://schemas.openxmlformats.org/officeDocument/2006/customXml" ds:itemID="{DD870300-B03F-45F7-9154-521D8C74684E}">
   <ds:schemaRefs>
+    <ds:schemaRef ds:uri="http://schemas.microsoft.com/office/2006/documentManagement/types"/>
+    <ds:schemaRef ds:uri="http://schemas.microsoft.com/office/2006/metadata/properties"/>
     <ds:schemaRef ds:uri="http://schemas.microsoft.com/office/infopath/2007/PartnerControls"/>
+    <ds:schemaRef ds:uri="http://purl.org/dc/elements/1.1/"/>
+    <ds:schemaRef ds:uri="fee82e44-1fa4-4144-8309-00fed2bf4198"/>
+    <ds:schemaRef ds:uri="http://schemas.openxmlformats.org/package/2006/metadata/core-properties"/>
+    <ds:schemaRef ds:uri="http://purl.org/dc/dcmitype/"/>
+    <ds:schemaRef ds:uri="1a61c928-f5f6-4989-bd5d-cb8872a1b06d"/>
     <ds:schemaRef ds:uri="http://www.w3.org/XML/1998/namespace"/>
-    <ds:schemaRef ds:uri="http://purl.org/dc/elements/1.1/"/>
-    <ds:schemaRef ds:uri="http://purl.org/dc/dcmitype/"/>
-    <ds:schemaRef ds:uri="75babd23-c2cf-47da-905c-780ef1259ee5"/>
-    <ds:schemaRef ds:uri="http://schemas.openxmlformats.org/package/2006/metadata/core-properties"/>
-    <ds:schemaRef ds:uri="http://schemas.microsoft.com/office/2006/documentManagement/types"/>
-    <ds:schemaRef ds:uri="360ff5ef-2e36-4a84-827b-5ed8ae650f03"/>
-    <ds:schemaRef ds:uri="http://schemas.microsoft.com/office/2006/metadata/properties"/>
     <ds:schemaRef ds:uri="http://purl.org/dc/terms/"/>
   </ds:schemaRefs>
 </ds:datastoreItem>
@@ -10961,5 +10914,20 @@
 </file>
 
 <file path=customXml/itemProps3.xml><?xml version="1.0" encoding="utf-8"?>
-<ds:datastoreItem xmlns:ds="http://schemas.openxmlformats.org/officeDocument/2006/customXml" ds:itemID="{F1F3BB61-48A8-4099-ABA2-F1821940A282}"/>
+<ds:datastoreItem xmlns:ds="http://schemas.openxmlformats.org/officeDocument/2006/customXml" ds:itemID="{F1F3BB61-48A8-4099-ABA2-F1821940A282}">
+  <ds:schemaRefs>
+    <ds:schemaRef ds:uri="http://schemas.microsoft.com/office/2006/metadata/contentType"/>
+    <ds:schemaRef ds:uri="http://schemas.microsoft.com/office/2006/metadata/properties/metaAttributes"/>
+    <ds:schemaRef ds:uri="http://www.w3.org/2001/XMLSchema"/>
+    <ds:schemaRef ds:uri="http://schemas.microsoft.com/office/2006/metadata/properties"/>
+    <ds:schemaRef ds:uri="fee82e44-1fa4-4144-8309-00fed2bf4198"/>
+    <ds:schemaRef ds:uri="1a61c928-f5f6-4989-bd5d-cb8872a1b06d"/>
+    <ds:schemaRef ds:uri="http://schemas.microsoft.com/office/2006/documentManagement/types"/>
+    <ds:schemaRef ds:uri="http://schemas.microsoft.com/office/infopath/2007/PartnerControls"/>
+    <ds:schemaRef ds:uri="http://schemas.openxmlformats.org/package/2006/metadata/core-properties"/>
+    <ds:schemaRef ds:uri="http://purl.org/dc/elements/1.1/"/>
+    <ds:schemaRef ds:uri="http://purl.org/dc/terms/"/>
+    <ds:schemaRef ds:uri="http://schemas.microsoft.com/internal/obd"/>
+  </ds:schemaRefs>
+</ds:datastoreItem>
 </file>
</xml_diff>